<commit_message>
Updates following recording of lectures
</commit_message>
<xml_diff>
--- a/Lectures/Lecture 09.1 NHST.pptx
+++ b/Lectures/Lecture 09.1 NHST.pptx
@@ -233,7 +233,7 @@
           <a:p>
             <a:fld id="{9FB01288-9136-467D-9DC0-9664A6086215}" type="datetimeFigureOut">
               <a:rPr lang="en-GB" smtClean="0"/>
-              <a:t>08/08/2024</a:t>
+              <a:t>12/09/2024</a:t>
             </a:fld>
             <a:endParaRPr lang="en-GB"/>
           </a:p>
@@ -842,7 +842,7 @@
           <a:p>
             <a:fld id="{5D4BFC96-C5AD-4B8C-B2E4-AF6E6CF7ECBA}" type="datetimeFigureOut">
               <a:rPr lang="en-GB" smtClean="0"/>
-              <a:t>08/08/2024</a:t>
+              <a:t>12/09/2024</a:t>
             </a:fld>
             <a:endParaRPr lang="en-GB"/>
           </a:p>
@@ -1052,7 +1052,7 @@
           <a:p>
             <a:fld id="{5D4BFC96-C5AD-4B8C-B2E4-AF6E6CF7ECBA}" type="datetimeFigureOut">
               <a:rPr lang="en-GB" smtClean="0"/>
-              <a:t>08/08/2024</a:t>
+              <a:t>12/09/2024</a:t>
             </a:fld>
             <a:endParaRPr lang="en-GB"/>
           </a:p>
@@ -1274,7 +1274,7 @@
           <a:p>
             <a:fld id="{5D4BFC96-C5AD-4B8C-B2E4-AF6E6CF7ECBA}" type="datetimeFigureOut">
               <a:rPr lang="en-GB" smtClean="0"/>
-              <a:t>08/08/2024</a:t>
+              <a:t>12/09/2024</a:t>
             </a:fld>
             <a:endParaRPr lang="en-GB"/>
           </a:p>
@@ -2213,7 +2213,7 @@
           <a:p>
             <a:fld id="{5D4BFC96-C5AD-4B8C-B2E4-AF6E6CF7ECBA}" type="datetimeFigureOut">
               <a:rPr lang="en-GB" smtClean="0"/>
-              <a:t>08/08/2024</a:t>
+              <a:t>12/09/2024</a:t>
             </a:fld>
             <a:endParaRPr lang="en-GB"/>
           </a:p>
@@ -2355,7 +2355,7 @@
           <a:p>
             <a:fld id="{5D4BFC96-C5AD-4B8C-B2E4-AF6E6CF7ECBA}" type="datetimeFigureOut">
               <a:rPr lang="en-GB" smtClean="0"/>
-              <a:t>08/08/2024</a:t>
+              <a:t>12/09/2024</a:t>
             </a:fld>
             <a:endParaRPr lang="en-GB"/>
           </a:p>
@@ -2468,7 +2468,7 @@
           <a:p>
             <a:fld id="{5D4BFC96-C5AD-4B8C-B2E4-AF6E6CF7ECBA}" type="datetimeFigureOut">
               <a:rPr lang="en-GB" smtClean="0"/>
-              <a:t>08/08/2024</a:t>
+              <a:t>12/09/2024</a:t>
             </a:fld>
             <a:endParaRPr lang="en-GB"/>
           </a:p>
@@ -2781,7 +2781,7 @@
           <a:p>
             <a:fld id="{5D4BFC96-C5AD-4B8C-B2E4-AF6E6CF7ECBA}" type="datetimeFigureOut">
               <a:rPr lang="en-GB" smtClean="0"/>
-              <a:t>08/08/2024</a:t>
+              <a:t>12/09/2024</a:t>
             </a:fld>
             <a:endParaRPr lang="en-GB"/>
           </a:p>
@@ -3074,7 +3074,7 @@
           <a:p>
             <a:fld id="{5D4BFC96-C5AD-4B8C-B2E4-AF6E6CF7ECBA}" type="datetimeFigureOut">
               <a:rPr lang="en-GB" smtClean="0"/>
-              <a:t>08/08/2024</a:t>
+              <a:t>12/09/2024</a:t>
             </a:fld>
             <a:endParaRPr lang="en-GB"/>
           </a:p>
@@ -3317,7 +3317,7 @@
           <a:p>
             <a:fld id="{5D4BFC96-C5AD-4B8C-B2E4-AF6E6CF7ECBA}" type="datetimeFigureOut">
               <a:rPr lang="en-GB" smtClean="0"/>
-              <a:t>08/08/2024</a:t>
+              <a:t>12/09/2024</a:t>
             </a:fld>
             <a:endParaRPr lang="en-GB"/>
           </a:p>
@@ -3801,6 +3801,18 @@
   <p:clrMapOvr>
     <a:masterClrMapping/>
   </p:clrMapOvr>
+  <mc:AlternateContent xmlns:mc="http://schemas.openxmlformats.org/markup-compatibility/2006" xmlns:p14="http://schemas.microsoft.com/office/powerpoint/2010/main">
+    <mc:Choice Requires="p14">
+      <p:transition spd="med" p14:dur="700">
+        <p:fade/>
+      </p:transition>
+    </mc:Choice>
+    <mc:Fallback xmlns="">
+      <p:transition spd="med">
+        <p:fade/>
+      </p:transition>
+    </mc:Fallback>
+  </mc:AlternateContent>
 </p:sld>
 </file>
 
@@ -3880,7 +3892,7 @@
             </a:r>
             <a:r>
               <a:rPr lang="en-GB" dirty="0"/>
-              <a:t> that we would observe a 1.7 m tall penguin</a:t>
+              <a:t> that we would observe a 1.56 m tall penguin</a:t>
             </a:r>
           </a:p>
           <a:p>
@@ -3899,10 +3911,10 @@
       </p:sp>
       <p:pic>
         <p:nvPicPr>
-          <p:cNvPr id="28" name="Picture Placeholder 27" descr="A graph of a penguin&#10;&#10;Description automatically generated">
+          <p:cNvPr id="7" name="Picture Placeholder 6" descr="A graph of a penguin&#10;&#10;Description automatically generated">
             <a:extLst>
               <a:ext uri="{FF2B5EF4-FFF2-40B4-BE49-F238E27FC236}">
-                <a16:creationId xmlns:a16="http://schemas.microsoft.com/office/drawing/2014/main" id="{41EEF88A-D43C-92CC-E85C-8C1ED804645C}"/>
+                <a16:creationId xmlns:a16="http://schemas.microsoft.com/office/drawing/2014/main" id="{6B6C78C7-DCBB-F3C8-E995-16FA42CE1031}"/>
               </a:ext>
             </a:extLst>
           </p:cNvPr>
@@ -3938,6 +3950,18 @@
   <p:clrMapOvr>
     <a:masterClrMapping/>
   </p:clrMapOvr>
+  <mc:AlternateContent xmlns:mc="http://schemas.openxmlformats.org/markup-compatibility/2006" xmlns:p14="http://schemas.microsoft.com/office/powerpoint/2010/main">
+    <mc:Choice Requires="p14">
+      <p:transition spd="med" p14:dur="700">
+        <p:fade/>
+      </p:transition>
+    </mc:Choice>
+    <mc:Fallback xmlns="">
+      <p:transition spd="med">
+        <p:fade/>
+      </p:transition>
+    </mc:Fallback>
+  </mc:AlternateContent>
   <p:timing>
     <p:tnLst>
       <p:par>
@@ -4001,21 +4025,39 @@
                                   </p:childTnLst>
                                 </p:cTn>
                               </p:par>
+                            </p:childTnLst>
+                          </p:cTn>
+                        </p:par>
+                      </p:childTnLst>
+                    </p:cTn>
+                  </p:par>
+                  <p:par>
+                    <p:cTn id="8" fill="hold">
+                      <p:stCondLst>
+                        <p:cond delay="indefinite"/>
+                      </p:stCondLst>
+                      <p:childTnLst>
+                        <p:par>
+                          <p:cTn id="9" fill="hold">
+                            <p:stCondLst>
+                              <p:cond delay="0"/>
+                            </p:stCondLst>
+                            <p:childTnLst>
                               <p:par>
-                                <p:cTn id="8" presetID="10" presetClass="entr" presetSubtype="0" fill="hold" nodeType="withEffect">
+                                <p:cTn id="10" presetID="10" presetClass="entr" presetSubtype="0" fill="hold" nodeType="clickEffect">
                                   <p:stCondLst>
                                     <p:cond delay="0"/>
                                   </p:stCondLst>
                                   <p:childTnLst>
                                     <p:set>
                                       <p:cBhvr>
-                                        <p:cTn id="9" dur="1" fill="hold">
+                                        <p:cTn id="11" dur="1" fill="hold">
                                           <p:stCondLst>
                                             <p:cond delay="0"/>
                                           </p:stCondLst>
                                         </p:cTn>
                                         <p:tgtEl>
-                                          <p:spTgt spid="28"/>
+                                          <p:spTgt spid="7"/>
                                         </p:tgtEl>
                                         <p:attrNameLst>
                                           <p:attrName>style.visibility</p:attrName>
@@ -4027,9 +4069,9 @@
                                     </p:set>
                                     <p:animEffect transition="in" filter="fade">
                                       <p:cBhvr>
-                                        <p:cTn id="10" dur="500"/>
-                                        <p:tgtEl>
-                                          <p:spTgt spid="28"/>
+                                        <p:cTn id="12" dur="500"/>
+                                        <p:tgtEl>
+                                          <p:spTgt spid="7"/>
                                         </p:tgtEl>
                                       </p:cBhvr>
                                     </p:animEffect>
@@ -4043,26 +4085,26 @@
                     </p:cTn>
                   </p:par>
                   <p:par>
-                    <p:cTn id="11" fill="hold">
+                    <p:cTn id="13" fill="hold">
                       <p:stCondLst>
                         <p:cond delay="indefinite"/>
                       </p:stCondLst>
                       <p:childTnLst>
                         <p:par>
-                          <p:cTn id="12" fill="hold">
+                          <p:cTn id="14" fill="hold">
                             <p:stCondLst>
                               <p:cond delay="0"/>
                             </p:stCondLst>
                             <p:childTnLst>
                               <p:par>
-                                <p:cTn id="13" presetID="10" presetClass="entr" presetSubtype="0" fill="hold" grpId="0" nodeType="clickEffect">
+                                <p:cTn id="15" presetID="10" presetClass="entr" presetSubtype="0" fill="hold" grpId="0" nodeType="clickEffect">
                                   <p:stCondLst>
                                     <p:cond delay="0"/>
                                   </p:stCondLst>
                                   <p:childTnLst>
                                     <p:set>
                                       <p:cBhvr>
-                                        <p:cTn id="14" dur="1" fill="hold">
+                                        <p:cTn id="16" dur="1" fill="hold">
                                           <p:stCondLst>
                                             <p:cond delay="0"/>
                                           </p:stCondLst>
@@ -4084,7 +4126,7 @@
                                     </p:set>
                                     <p:animEffect transition="in" filter="fade">
                                       <p:cBhvr>
-                                        <p:cTn id="15" dur="500"/>
+                                        <p:cTn id="17" dur="500"/>
                                         <p:tgtEl>
                                           <p:spTgt spid="3">
                                             <p:txEl>
@@ -4104,26 +4146,26 @@
                     </p:cTn>
                   </p:par>
                   <p:par>
-                    <p:cTn id="16" fill="hold">
+                    <p:cTn id="18" fill="hold">
                       <p:stCondLst>
                         <p:cond delay="indefinite"/>
                       </p:stCondLst>
                       <p:childTnLst>
                         <p:par>
-                          <p:cTn id="17" fill="hold">
+                          <p:cTn id="19" fill="hold">
                             <p:stCondLst>
                               <p:cond delay="0"/>
                             </p:stCondLst>
                             <p:childTnLst>
                               <p:par>
-                                <p:cTn id="18" presetID="10" presetClass="entr" presetSubtype="0" fill="hold" grpId="0" nodeType="clickEffect">
+                                <p:cTn id="20" presetID="10" presetClass="entr" presetSubtype="0" fill="hold" grpId="0" nodeType="clickEffect">
                                   <p:stCondLst>
                                     <p:cond delay="0"/>
                                   </p:stCondLst>
                                   <p:childTnLst>
                                     <p:set>
                                       <p:cBhvr>
-                                        <p:cTn id="19" dur="1" fill="hold">
+                                        <p:cTn id="21" dur="1" fill="hold">
                                           <p:stCondLst>
                                             <p:cond delay="0"/>
                                           </p:stCondLst>
@@ -4145,7 +4187,7 @@
                                     </p:set>
                                     <p:animEffect transition="in" filter="fade">
                                       <p:cBhvr>
-                                        <p:cTn id="20" dur="500"/>
+                                        <p:cTn id="22" dur="500"/>
                                         <p:tgtEl>
                                           <p:spTgt spid="3">
                                             <p:txEl>
@@ -4280,17 +4322,17 @@
           <a:p>
             <a:r>
               <a:rPr lang="en-GB" dirty="0"/>
-              <a:t>Area under the curve includes our 1.7 m tall penguin</a:t>
+              <a:t>Area under the curve includes our 1.56 m tall penguin</a:t>
             </a:r>
           </a:p>
         </p:txBody>
       </p:sp>
       <p:pic>
         <p:nvPicPr>
-          <p:cNvPr id="17" name="Picture Placeholder 16" descr="A graph of a penguin&#10;&#10;Description automatically generated with medium confidence">
+          <p:cNvPr id="11" name="Picture Placeholder 10" descr="A graph of a penguin&#10;&#10;Description automatically generated">
             <a:extLst>
               <a:ext uri="{FF2B5EF4-FFF2-40B4-BE49-F238E27FC236}">
-                <a16:creationId xmlns:a16="http://schemas.microsoft.com/office/drawing/2014/main" id="{749BF699-BE0E-D1D0-DE5C-7361C51F4BC8}"/>
+                <a16:creationId xmlns:a16="http://schemas.microsoft.com/office/drawing/2014/main" id="{BE34A20B-0197-0D9F-9D01-FBC8427F41F1}"/>
               </a:ext>
             </a:extLst>
           </p:cNvPr>
@@ -4326,6 +4368,18 @@
   <p:clrMapOvr>
     <a:masterClrMapping/>
   </p:clrMapOvr>
+  <mc:AlternateContent xmlns:mc="http://schemas.openxmlformats.org/markup-compatibility/2006" xmlns:p14="http://schemas.microsoft.com/office/powerpoint/2010/main">
+    <mc:Choice Requires="p14">
+      <p:transition spd="med" p14:dur="700">
+        <p:fade/>
+      </p:transition>
+    </mc:Choice>
+    <mc:Fallback xmlns="">
+      <p:transition spd="med">
+        <p:fade/>
+      </p:transition>
+    </mc:Fallback>
+  </mc:AlternateContent>
   <p:timing>
     <p:tnLst>
       <p:par>
@@ -4674,20 +4728,20 @@
           <a:p>
             <a:r>
               <a:rPr lang="en-GB" dirty="0"/>
-              <a:t>99.75% of penguins between 0.71 m and 1.56 m tall</a:t>
+              <a:t>99.5% of penguins between 0.71 m and 1.56 m tall</a:t>
             </a:r>
           </a:p>
           <a:p>
             <a:pPr lvl="1"/>
             <a:r>
               <a:rPr lang="en-GB" dirty="0"/>
-              <a:t>So, a 99.75% probability that if we measured a penguin, they’d be within that range</a:t>
+              <a:t>So, a 99.5% probability that if we measured a penguin, they’d be within that range</a:t>
             </a:r>
           </a:p>
           <a:p>
             <a:r>
               <a:rPr lang="en-GB" dirty="0"/>
-              <a:t>0.25% of penguins are greater than 1.56 m tall</a:t>
+              <a:t>0.25% of penguins are greater than or equal to 1.56 m tall</a:t>
             </a:r>
           </a:p>
           <a:p>
@@ -4695,23 +4749,16 @@
             <a:r>
               <a:rPr lang="en-GB" dirty="0"/>
               <a:t>So, a 0.25% probability that each time we measure a penguin, it will be greater than 1.56 cm tall</a:t>
-            </a:r>
-          </a:p>
-          <a:p>
-            <a:pPr lvl="1"/>
-            <a:r>
-              <a:rPr lang="en-GB" dirty="0"/>
-              <a:t>Including 1.7 m tall</a:t>
             </a:r>
           </a:p>
         </p:txBody>
       </p:sp>
       <p:pic>
         <p:nvPicPr>
-          <p:cNvPr id="18" name="Picture Placeholder 17" descr="A green and white graph&#10;&#10;Description automatically generated">
+          <p:cNvPr id="11" name="Picture Placeholder 10" descr="A green and white graph&#10;&#10;Description automatically generated">
             <a:extLst>
               <a:ext uri="{FF2B5EF4-FFF2-40B4-BE49-F238E27FC236}">
-                <a16:creationId xmlns:a16="http://schemas.microsoft.com/office/drawing/2014/main" id="{9E5D9426-F8D3-0E1F-F687-14D5AA6D7F95}"/>
+                <a16:creationId xmlns:a16="http://schemas.microsoft.com/office/drawing/2014/main" id="{CF05F0C6-6ADD-0590-F462-A9516FE73832}"/>
               </a:ext>
             </a:extLst>
           </p:cNvPr>
@@ -4747,6 +4794,18 @@
   <p:clrMapOvr>
     <a:masterClrMapping/>
   </p:clrMapOvr>
+  <mc:AlternateContent xmlns:mc="http://schemas.openxmlformats.org/markup-compatibility/2006" xmlns:p14="http://schemas.microsoft.com/office/powerpoint/2010/main">
+    <mc:Choice Requires="p14">
+      <p:transition spd="med" p14:dur="700">
+        <p:fade/>
+      </p:transition>
+    </mc:Choice>
+    <mc:Fallback xmlns="">
+      <p:transition spd="med">
+        <p:fade/>
+      </p:transition>
+    </mc:Fallback>
+  </mc:AlternateContent>
   <p:timing>
     <p:tnLst>
       <p:par>
@@ -4985,67 +5044,6 @@
                                           <p:spTgt spid="3">
                                             <p:txEl>
                                               <p:pRg st="3" end="3"/>
-                                            </p:txEl>
-                                          </p:spTgt>
-                                        </p:tgtEl>
-                                      </p:cBhvr>
-                                    </p:animEffect>
-                                  </p:childTnLst>
-                                </p:cTn>
-                              </p:par>
-                            </p:childTnLst>
-                          </p:cTn>
-                        </p:par>
-                      </p:childTnLst>
-                    </p:cTn>
-                  </p:par>
-                  <p:par>
-                    <p:cTn id="23" fill="hold">
-                      <p:stCondLst>
-                        <p:cond delay="indefinite"/>
-                      </p:stCondLst>
-                      <p:childTnLst>
-                        <p:par>
-                          <p:cTn id="24" fill="hold">
-                            <p:stCondLst>
-                              <p:cond delay="0"/>
-                            </p:stCondLst>
-                            <p:childTnLst>
-                              <p:par>
-                                <p:cTn id="25" presetID="10" presetClass="entr" presetSubtype="0" fill="hold" grpId="0" nodeType="clickEffect">
-                                  <p:stCondLst>
-                                    <p:cond delay="0"/>
-                                  </p:stCondLst>
-                                  <p:childTnLst>
-                                    <p:set>
-                                      <p:cBhvr>
-                                        <p:cTn id="26" dur="1" fill="hold">
-                                          <p:stCondLst>
-                                            <p:cond delay="0"/>
-                                          </p:stCondLst>
-                                        </p:cTn>
-                                        <p:tgtEl>
-                                          <p:spTgt spid="3">
-                                            <p:txEl>
-                                              <p:pRg st="4" end="4"/>
-                                            </p:txEl>
-                                          </p:spTgt>
-                                        </p:tgtEl>
-                                        <p:attrNameLst>
-                                          <p:attrName>style.visibility</p:attrName>
-                                        </p:attrNameLst>
-                                      </p:cBhvr>
-                                      <p:to>
-                                        <p:strVal val="visible"/>
-                                      </p:to>
-                                    </p:set>
-                                    <p:animEffect transition="in" filter="fade">
-                                      <p:cBhvr>
-                                        <p:cTn id="27" dur="500"/>
-                                        <p:tgtEl>
-                                          <p:spTgt spid="3">
-                                            <p:txEl>
-                                              <p:pRg st="4" end="4"/>
                                             </p:txEl>
                                           </p:spTgt>
                                         </p:tgtEl>
@@ -5156,7 +5154,7 @@
           <a:p>
             <a:r>
               <a:rPr lang="en-GB" dirty="0"/>
-              <a:t>Either this 1.7 m tall penguin came from the same distribution</a:t>
+              <a:t>Either this 1.56 m tall penguin came from the same distribution</a:t>
             </a:r>
           </a:p>
           <a:p>
@@ -5201,10 +5199,10 @@
       </p:sp>
       <p:pic>
         <p:nvPicPr>
-          <p:cNvPr id="22" name="Picture Placeholder 21" descr="A graph of a penguin&#10;&#10;Description automatically generated with medium confidence">
+          <p:cNvPr id="11" name="Picture Placeholder 10">
             <a:extLst>
               <a:ext uri="{FF2B5EF4-FFF2-40B4-BE49-F238E27FC236}">
-                <a16:creationId xmlns:a16="http://schemas.microsoft.com/office/drawing/2014/main" id="{47F9B64B-C590-23AE-9EF9-6D4BCBA3A2A4}"/>
+                <a16:creationId xmlns:a16="http://schemas.microsoft.com/office/drawing/2014/main" id="{12517485-F907-0B93-4B2D-FE6421F4EED0}"/>
               </a:ext>
             </a:extLst>
           </p:cNvPr>
@@ -5232,10 +5230,10 @@
       </p:pic>
       <p:pic>
         <p:nvPicPr>
-          <p:cNvPr id="23" name="Picture Placeholder 27" descr="A graph of a penguin&#10;&#10;Description automatically generated">
+          <p:cNvPr id="5" name="Picture 4" descr="A graph of a penguin&#10;&#10;Description automatically generated">
             <a:extLst>
               <a:ext uri="{FF2B5EF4-FFF2-40B4-BE49-F238E27FC236}">
-                <a16:creationId xmlns:a16="http://schemas.microsoft.com/office/drawing/2014/main" id="{BCA6BB61-4829-EBE0-04AE-5B0809D4C8D3}"/>
+                <a16:creationId xmlns:a16="http://schemas.microsoft.com/office/drawing/2014/main" id="{4A33F4D0-2079-8608-C899-C85A5940CFE9}"/>
               </a:ext>
             </a:extLst>
           </p:cNvPr>
@@ -5252,7 +5250,6 @@
               </a:ext>
             </a:extLst>
           </a:blip>
-          <a:srcRect t="691" b="691"/>
           <a:stretch>
             <a:fillRect/>
           </a:stretch>
@@ -5260,7 +5257,7 @@
         <p:spPr>
           <a:xfrm>
             <a:off x="6359525" y="0"/>
-            <a:ext cx="5832475" cy="6858000"/>
+            <a:ext cx="5751871" cy="6858000"/>
           </a:xfrm>
           <a:prstGeom prst="rect">
             <a:avLst/>
@@ -5277,6 +5274,18 @@
   <p:clrMapOvr>
     <a:masterClrMapping/>
   </p:clrMapOvr>
+  <mc:AlternateContent xmlns:mc="http://schemas.openxmlformats.org/markup-compatibility/2006" xmlns:p14="http://schemas.microsoft.com/office/powerpoint/2010/main">
+    <mc:Choice Requires="p14">
+      <p:transition spd="med" p14:dur="700">
+        <p:fade/>
+      </p:transition>
+    </mc:Choice>
+    <mc:Fallback xmlns="">
+      <p:transition spd="med">
+        <p:fade/>
+      </p:transition>
+    </mc:Fallback>
+  </mc:AlternateContent>
   <p:timing>
     <p:tnLst>
       <p:par>
@@ -5472,7 +5481,7 @@
                                       <p:cBhvr>
                                         <p:cTn id="19" dur="500"/>
                                         <p:tgtEl>
-                                          <p:spTgt spid="23"/>
+                                          <p:spTgt spid="5"/>
                                         </p:tgtEl>
                                       </p:cBhvr>
                                     </p:animEffect>
@@ -5484,7 +5493,7 @@
                                           </p:stCondLst>
                                         </p:cTn>
                                         <p:tgtEl>
-                                          <p:spTgt spid="23"/>
+                                          <p:spTgt spid="5"/>
                                         </p:tgtEl>
                                         <p:attrNameLst>
                                           <p:attrName>style.visibility</p:attrName>
@@ -5728,7 +5737,7 @@
               <a:p>
                 <a:r>
                   <a:rPr lang="en-GB" dirty="0"/>
-                  <a:t>The P-value to see an extreme height, like our giant 1.7 m tall penguin, is:</a:t>
+                  <a:t>The P-value to see an extreme height, like our giant 1.56 m tall penguin, is:</a:t>
                 </a:r>
               </a:p>
               <a:p>
@@ -5749,7 +5758,7 @@
                 </a14:m>
                 <a:r>
                   <a:rPr lang="en-GB" dirty="0"/>
-                  <a:t> 1.7 m</a:t>
+                  <a:t> 1.56 m</a:t>
                 </a:r>
               </a:p>
               <a:p>
@@ -5794,7 +5803,13 @@
                       <a:rPr lang="en-GB" b="0" i="1" smtClean="0">
                         <a:latin typeface="Cambria Math" panose="02040503050406030204" pitchFamily="18" charset="0"/>
                       </a:rPr>
-                      <m:t>=0.0025+0.0025=0.005</m:t>
+                      <m:t>=0.0025+0.0025=0.005=0.5</m:t>
+                    </m:r>
+                    <m:r>
+                      <a:rPr lang="en-GB" b="0" i="1" smtClean="0">
+                        <a:latin typeface="Cambria Math" panose="02040503050406030204" pitchFamily="18" charset="0"/>
+                      </a:rPr>
+                      <m:t>%</m:t>
                     </m:r>
                   </m:oMath>
                 </a14:m>
@@ -5810,7 +5825,7 @@
               <a:p>
                 <a:r>
                   <a:rPr lang="en-GB" dirty="0"/>
-                  <a:t>0.5% chance our 1.7 m tall came from the same distribution as our “normal” penguins</a:t>
+                  <a:t>0.5% chance our 1.56 m penguin came from the same distribution as our “normal” penguins</a:t>
                 </a:r>
               </a:p>
             </p:txBody>
@@ -5862,10 +5877,10 @@
       </mc:AlternateContent>
       <p:pic>
         <p:nvPicPr>
-          <p:cNvPr id="11" name="Picture Placeholder 10" descr="A green and white graph&#10;&#10;Description automatically generated">
+          <p:cNvPr id="7" name="Picture Placeholder 6" descr="A green and white graph&#10;&#10;Description automatically generated">
             <a:extLst>
               <a:ext uri="{FF2B5EF4-FFF2-40B4-BE49-F238E27FC236}">
-                <a16:creationId xmlns:a16="http://schemas.microsoft.com/office/drawing/2014/main" id="{488EE6EB-7E41-213E-8DCD-EC9D5FA104A5}"/>
+                <a16:creationId xmlns:a16="http://schemas.microsoft.com/office/drawing/2014/main" id="{4D0B505C-B907-9616-0952-90978A3C0335}"/>
               </a:ext>
             </a:extLst>
           </p:cNvPr>
@@ -5901,6 +5916,18 @@
   <p:clrMapOvr>
     <a:masterClrMapping/>
   </p:clrMapOvr>
+  <mc:AlternateContent xmlns:mc="http://schemas.openxmlformats.org/markup-compatibility/2006" xmlns:p14="http://schemas.microsoft.com/office/powerpoint/2010/main">
+    <mc:Choice Requires="p14">
+      <p:transition spd="med" p14:dur="700">
+        <p:fade/>
+      </p:transition>
+    </mc:Choice>
+    <mc:Fallback xmlns="">
+      <p:transition spd="med">
+        <p:fade/>
+      </p:transition>
+    </mc:Fallback>
+  </mc:AlternateContent>
   <p:timing>
     <p:tnLst>
       <p:par>
@@ -5964,33 +5991,15 @@
                                   </p:childTnLst>
                                 </p:cTn>
                               </p:par>
-                            </p:childTnLst>
-                          </p:cTn>
-                        </p:par>
-                      </p:childTnLst>
-                    </p:cTn>
-                  </p:par>
-                  <p:par>
-                    <p:cTn id="8" fill="hold">
-                      <p:stCondLst>
-                        <p:cond delay="indefinite"/>
-                      </p:stCondLst>
-                      <p:childTnLst>
-                        <p:par>
-                          <p:cTn id="9" fill="hold">
-                            <p:stCondLst>
-                              <p:cond delay="0"/>
-                            </p:stCondLst>
-                            <p:childTnLst>
                               <p:par>
-                                <p:cTn id="10" presetID="10" presetClass="entr" presetSubtype="0" fill="hold" grpId="0" nodeType="clickEffect">
+                                <p:cTn id="8" presetID="10" presetClass="entr" presetSubtype="0" fill="hold" grpId="0" nodeType="withEffect">
                                   <p:stCondLst>
                                     <p:cond delay="0"/>
                                   </p:stCondLst>
                                   <p:childTnLst>
                                     <p:set>
                                       <p:cBhvr>
-                                        <p:cTn id="11" dur="1" fill="hold">
+                                        <p:cTn id="9" dur="1" fill="hold">
                                           <p:stCondLst>
                                             <p:cond delay="0"/>
                                           </p:stCondLst>
@@ -6012,7 +6021,7 @@
                                     </p:set>
                                     <p:animEffect transition="in" filter="fade">
                                       <p:cBhvr>
-                                        <p:cTn id="12" dur="500"/>
+                                        <p:cTn id="10" dur="500"/>
                                         <p:tgtEl>
                                           <p:spTgt spid="3">
                                             <p:txEl>
@@ -6025,33 +6034,15 @@
                                   </p:childTnLst>
                                 </p:cTn>
                               </p:par>
-                            </p:childTnLst>
-                          </p:cTn>
-                        </p:par>
-                      </p:childTnLst>
-                    </p:cTn>
-                  </p:par>
-                  <p:par>
-                    <p:cTn id="13" fill="hold">
-                      <p:stCondLst>
-                        <p:cond delay="indefinite"/>
-                      </p:stCondLst>
-                      <p:childTnLst>
-                        <p:par>
-                          <p:cTn id="14" fill="hold">
-                            <p:stCondLst>
-                              <p:cond delay="0"/>
-                            </p:stCondLst>
-                            <p:childTnLst>
                               <p:par>
-                                <p:cTn id="15" presetID="10" presetClass="entr" presetSubtype="0" fill="hold" grpId="0" nodeType="clickEffect">
+                                <p:cTn id="11" presetID="10" presetClass="entr" presetSubtype="0" fill="hold" grpId="0" nodeType="withEffect">
                                   <p:stCondLst>
                                     <p:cond delay="0"/>
                                   </p:stCondLst>
                                   <p:childTnLst>
                                     <p:set>
                                       <p:cBhvr>
-                                        <p:cTn id="16" dur="1" fill="hold">
+                                        <p:cTn id="12" dur="1" fill="hold">
                                           <p:stCondLst>
                                             <p:cond delay="0"/>
                                           </p:stCondLst>
@@ -6073,7 +6064,7 @@
                                     </p:set>
                                     <p:animEffect transition="in" filter="fade">
                                       <p:cBhvr>
-                                        <p:cTn id="17" dur="500"/>
+                                        <p:cTn id="13" dur="500"/>
                                         <p:tgtEl>
                                           <p:spTgt spid="3">
                                             <p:txEl>
@@ -6086,32 +6077,100 @@
                                   </p:childTnLst>
                                 </p:cTn>
                               </p:par>
-                            </p:childTnLst>
-                          </p:cTn>
-                        </p:par>
-                      </p:childTnLst>
-                    </p:cTn>
-                  </p:par>
-                  <p:par>
-                    <p:cTn id="18" fill="hold">
-                      <p:stCondLst>
-                        <p:cond delay="indefinite"/>
-                      </p:stCondLst>
-                      <p:childTnLst>
-                        <p:par>
-                          <p:cTn id="19" fill="hold">
-                            <p:stCondLst>
-                              <p:cond delay="0"/>
-                            </p:stCondLst>
-                            <p:childTnLst>
                               <p:par>
-                                <p:cTn id="20" presetID="10" presetClass="entr" presetSubtype="0" fill="hold" grpId="0" nodeType="clickEffect">
+                                <p:cTn id="14" presetID="10" presetClass="entr" presetSubtype="0" fill="hold" grpId="0" nodeType="withEffect">
                                   <p:stCondLst>
                                     <p:cond delay="0"/>
                                   </p:stCondLst>
                                   <p:childTnLst>
                                     <p:set>
                                       <p:cBhvr>
+                                        <p:cTn id="15" dur="1" fill="hold">
+                                          <p:stCondLst>
+                                            <p:cond delay="0"/>
+                                          </p:stCondLst>
+                                        </p:cTn>
+                                        <p:tgtEl>
+                                          <p:spTgt spid="3">
+                                            <p:txEl>
+                                              <p:pRg st="3" end="3"/>
+                                            </p:txEl>
+                                          </p:spTgt>
+                                        </p:tgtEl>
+                                        <p:attrNameLst>
+                                          <p:attrName>style.visibility</p:attrName>
+                                        </p:attrNameLst>
+                                      </p:cBhvr>
+                                      <p:to>
+                                        <p:strVal val="visible"/>
+                                      </p:to>
+                                    </p:set>
+                                    <p:animEffect transition="in" filter="fade">
+                                      <p:cBhvr>
+                                        <p:cTn id="16" dur="500"/>
+                                        <p:tgtEl>
+                                          <p:spTgt spid="3">
+                                            <p:txEl>
+                                              <p:pRg st="3" end="3"/>
+                                            </p:txEl>
+                                          </p:spTgt>
+                                        </p:tgtEl>
+                                      </p:cBhvr>
+                                    </p:animEffect>
+                                  </p:childTnLst>
+                                </p:cTn>
+                              </p:par>
+                              <p:par>
+                                <p:cTn id="17" presetID="10" presetClass="entr" presetSubtype="0" fill="hold" grpId="0" nodeType="withEffect">
+                                  <p:stCondLst>
+                                    <p:cond delay="0"/>
+                                  </p:stCondLst>
+                                  <p:childTnLst>
+                                    <p:set>
+                                      <p:cBhvr>
+                                        <p:cTn id="18" dur="1" fill="hold">
+                                          <p:stCondLst>
+                                            <p:cond delay="0"/>
+                                          </p:stCondLst>
+                                        </p:cTn>
+                                        <p:tgtEl>
+                                          <p:spTgt spid="3">
+                                            <p:txEl>
+                                              <p:pRg st="4" end="4"/>
+                                            </p:txEl>
+                                          </p:spTgt>
+                                        </p:tgtEl>
+                                        <p:attrNameLst>
+                                          <p:attrName>style.visibility</p:attrName>
+                                        </p:attrNameLst>
+                                      </p:cBhvr>
+                                      <p:to>
+                                        <p:strVal val="visible"/>
+                                      </p:to>
+                                    </p:set>
+                                    <p:animEffect transition="in" filter="fade">
+                                      <p:cBhvr>
+                                        <p:cTn id="19" dur="500"/>
+                                        <p:tgtEl>
+                                          <p:spTgt spid="3">
+                                            <p:txEl>
+                                              <p:pRg st="4" end="4"/>
+                                            </p:txEl>
+                                          </p:spTgt>
+                                        </p:tgtEl>
+                                      </p:cBhvr>
+                                    </p:animEffect>
+                                  </p:childTnLst>
+                                </p:cTn>
+                              </p:par>
+                              <p:par>
+                                <p:cTn id="20" presetID="10" presetClass="entr" presetSubtype="0" fill="hold" grpId="0" nodeType="withEffect">
+                                  <p:stCondLst>
+                                    <p:cond delay="0"/>
+                                  </p:stCondLst>
+                                  <p:childTnLst>
+                                    <p:set>
+                                      <p:cBhvr>
                                         <p:cTn id="21" dur="1" fill="hold">
                                           <p:stCondLst>
                                             <p:cond delay="0"/>
@@ -6120,7 +6179,7 @@
                                         <p:tgtEl>
                                           <p:spTgt spid="3">
                                             <p:txEl>
-                                              <p:pRg st="3" end="3"/>
+                                              <p:pRg st="5" end="5"/>
                                             </p:txEl>
                                           </p:spTgt>
                                         </p:tgtEl>
@@ -6138,7 +6197,7 @@
                                         <p:tgtEl>
                                           <p:spTgt spid="3">
                                             <p:txEl>
-                                              <p:pRg st="3" end="3"/>
+                                              <p:pRg st="5" end="5"/>
                                             </p:txEl>
                                           </p:spTgt>
                                         </p:tgtEl>
@@ -6181,7 +6240,7 @@
                                         <p:tgtEl>
                                           <p:spTgt spid="3">
                                             <p:txEl>
-                                              <p:pRg st="4" end="4"/>
+                                              <p:pRg st="6" end="6"/>
                                             </p:txEl>
                                           </p:spTgt>
                                         </p:tgtEl>
@@ -6196,128 +6255,6 @@
                                     <p:animEffect transition="in" filter="fade">
                                       <p:cBhvr>
                                         <p:cTn id="27" dur="500"/>
-                                        <p:tgtEl>
-                                          <p:spTgt spid="3">
-                                            <p:txEl>
-                                              <p:pRg st="4" end="4"/>
-                                            </p:txEl>
-                                          </p:spTgt>
-                                        </p:tgtEl>
-                                      </p:cBhvr>
-                                    </p:animEffect>
-                                  </p:childTnLst>
-                                </p:cTn>
-                              </p:par>
-                            </p:childTnLst>
-                          </p:cTn>
-                        </p:par>
-                      </p:childTnLst>
-                    </p:cTn>
-                  </p:par>
-                  <p:par>
-                    <p:cTn id="28" fill="hold">
-                      <p:stCondLst>
-                        <p:cond delay="indefinite"/>
-                      </p:stCondLst>
-                      <p:childTnLst>
-                        <p:par>
-                          <p:cTn id="29" fill="hold">
-                            <p:stCondLst>
-                              <p:cond delay="0"/>
-                            </p:stCondLst>
-                            <p:childTnLst>
-                              <p:par>
-                                <p:cTn id="30" presetID="10" presetClass="entr" presetSubtype="0" fill="hold" grpId="0" nodeType="clickEffect">
-                                  <p:stCondLst>
-                                    <p:cond delay="0"/>
-                                  </p:stCondLst>
-                                  <p:childTnLst>
-                                    <p:set>
-                                      <p:cBhvr>
-                                        <p:cTn id="31" dur="1" fill="hold">
-                                          <p:stCondLst>
-                                            <p:cond delay="0"/>
-                                          </p:stCondLst>
-                                        </p:cTn>
-                                        <p:tgtEl>
-                                          <p:spTgt spid="3">
-                                            <p:txEl>
-                                              <p:pRg st="5" end="5"/>
-                                            </p:txEl>
-                                          </p:spTgt>
-                                        </p:tgtEl>
-                                        <p:attrNameLst>
-                                          <p:attrName>style.visibility</p:attrName>
-                                        </p:attrNameLst>
-                                      </p:cBhvr>
-                                      <p:to>
-                                        <p:strVal val="visible"/>
-                                      </p:to>
-                                    </p:set>
-                                    <p:animEffect transition="in" filter="fade">
-                                      <p:cBhvr>
-                                        <p:cTn id="32" dur="500"/>
-                                        <p:tgtEl>
-                                          <p:spTgt spid="3">
-                                            <p:txEl>
-                                              <p:pRg st="5" end="5"/>
-                                            </p:txEl>
-                                          </p:spTgt>
-                                        </p:tgtEl>
-                                      </p:cBhvr>
-                                    </p:animEffect>
-                                  </p:childTnLst>
-                                </p:cTn>
-                              </p:par>
-                            </p:childTnLst>
-                          </p:cTn>
-                        </p:par>
-                      </p:childTnLst>
-                    </p:cTn>
-                  </p:par>
-                  <p:par>
-                    <p:cTn id="33" fill="hold">
-                      <p:stCondLst>
-                        <p:cond delay="indefinite"/>
-                      </p:stCondLst>
-                      <p:childTnLst>
-                        <p:par>
-                          <p:cTn id="34" fill="hold">
-                            <p:stCondLst>
-                              <p:cond delay="0"/>
-                            </p:stCondLst>
-                            <p:childTnLst>
-                              <p:par>
-                                <p:cTn id="35" presetID="10" presetClass="entr" presetSubtype="0" fill="hold" grpId="0" nodeType="clickEffect">
-                                  <p:stCondLst>
-                                    <p:cond delay="0"/>
-                                  </p:stCondLst>
-                                  <p:childTnLst>
-                                    <p:set>
-                                      <p:cBhvr>
-                                        <p:cTn id="36" dur="1" fill="hold">
-                                          <p:stCondLst>
-                                            <p:cond delay="0"/>
-                                          </p:stCondLst>
-                                        </p:cTn>
-                                        <p:tgtEl>
-                                          <p:spTgt spid="3">
-                                            <p:txEl>
-                                              <p:pRg st="6" end="6"/>
-                                            </p:txEl>
-                                          </p:spTgt>
-                                        </p:tgtEl>
-                                        <p:attrNameLst>
-                                          <p:attrName>style.visibility</p:attrName>
-                                        </p:attrNameLst>
-                                      </p:cBhvr>
-                                      <p:to>
-                                        <p:strVal val="visible"/>
-                                      </p:to>
-                                    </p:set>
-                                    <p:animEffect transition="in" filter="fade">
-                                      <p:cBhvr>
-                                        <p:cTn id="37" dur="500"/>
                                         <p:tgtEl>
                                           <p:spTgt spid="3">
                                             <p:txEl>
@@ -6419,6 +6356,18 @@
   <p:clrMapOvr>
     <a:masterClrMapping/>
   </p:clrMapOvr>
+  <mc:AlternateContent xmlns:mc="http://schemas.openxmlformats.org/markup-compatibility/2006" xmlns:p14="http://schemas.microsoft.com/office/powerpoint/2010/main">
+    <mc:Choice Requires="p14">
+      <p:transition spd="med" p14:dur="700">
+        <p:fade/>
+      </p:transition>
+    </mc:Choice>
+    <mc:Fallback xmlns="">
+      <p:transition spd="med">
+        <p:fade/>
+      </p:transition>
+    </mc:Fallback>
+  </mc:AlternateContent>
 </p:sld>
 </file>
 
@@ -6568,7 +6517,7 @@
             <a:pPr lvl="1"/>
             <a:r>
               <a:rPr lang="en-GB" dirty="0"/>
-              <a:t>I.e. there is less than a 5% chance that the 1.7 m tall penguin came from the same distribution</a:t>
+              <a:t>I.e. there is less than a 5% chance that the 1.56 m tall penguin came from the same distribution</a:t>
             </a:r>
           </a:p>
         </p:txBody>
@@ -6820,6 +6769,18 @@
   <p:clrMapOvr>
     <a:masterClrMapping/>
   </p:clrMapOvr>
+  <mc:AlternateContent xmlns:mc="http://schemas.openxmlformats.org/markup-compatibility/2006" xmlns:p14="http://schemas.microsoft.com/office/powerpoint/2010/main">
+    <mc:Choice Requires="p14">
+      <p:transition spd="med" p14:dur="700">
+        <p:fade/>
+      </p:transition>
+    </mc:Choice>
+    <mc:Fallback xmlns="">
+      <p:transition spd="med">
+        <p:fade/>
+      </p:transition>
+    </mc:Fallback>
+  </mc:AlternateContent>
   <p:timing>
     <p:tnLst>
       <p:par>
@@ -7320,7 +7281,7 @@
                 <a:pPr lvl="1"/>
                 <a:r>
                   <a:rPr lang="en-GB" dirty="0"/>
-                  <a:t>The 1.7m tall penguin is part of the white distribution</a:t>
+                  <a:t>The 1.56m tall penguin is part of the white distribution</a:t>
                 </a:r>
                 <a:endParaRPr lang="en-GB" dirty="0">
                   <a:solidFill>
@@ -7621,10 +7582,10 @@
       </mc:AlternateContent>
       <p:pic>
         <p:nvPicPr>
-          <p:cNvPr id="13" name="Picture Placeholder 12" descr="A graph of a penguin&#10;&#10;Description automatically generated with medium confidence">
+          <p:cNvPr id="14" name="Picture Placeholder 13" descr="A graph of a penguin&#10;&#10;Description automatically generated">
             <a:extLst>
               <a:ext uri="{FF2B5EF4-FFF2-40B4-BE49-F238E27FC236}">
-                <a16:creationId xmlns:a16="http://schemas.microsoft.com/office/drawing/2014/main" id="{D1E7CE66-E6F7-70AC-2F2E-59592BE87DA6}"/>
+                <a16:creationId xmlns:a16="http://schemas.microsoft.com/office/drawing/2014/main" id="{3C197CA4-CB79-4FF4-8E3C-270B3D41BC08}"/>
               </a:ext>
             </a:extLst>
           </p:cNvPr>
@@ -7660,6 +7621,18 @@
   <p:clrMapOvr>
     <a:masterClrMapping/>
   </p:clrMapOvr>
+  <mc:AlternateContent xmlns:mc="http://schemas.openxmlformats.org/markup-compatibility/2006" xmlns:p14="http://schemas.microsoft.com/office/powerpoint/2010/main">
+    <mc:Choice Requires="p14">
+      <p:transition spd="med" p14:dur="700">
+        <p:fade/>
+      </p:transition>
+    </mc:Choice>
+    <mc:Fallback xmlns="">
+      <p:transition spd="med">
+        <p:fade/>
+      </p:transition>
+    </mc:Fallback>
+  </mc:AlternateContent>
   <p:timing>
     <p:tnLst>
       <p:par>
@@ -8458,6 +8431,18 @@
   <p:clrMapOvr>
     <a:masterClrMapping/>
   </p:clrMapOvr>
+  <mc:AlternateContent xmlns:mc="http://schemas.openxmlformats.org/markup-compatibility/2006" xmlns:p14="http://schemas.microsoft.com/office/powerpoint/2010/main">
+    <mc:Choice Requires="p14">
+      <p:transition spd="med" p14:dur="700">
+        <p:fade/>
+      </p:transition>
+    </mc:Choice>
+    <mc:Fallback xmlns="">
+      <p:transition spd="med">
+        <p:fade/>
+      </p:transition>
+    </mc:Fallback>
+  </mc:AlternateContent>
   <p:timing>
     <p:tnLst>
       <p:par>
@@ -9034,6 +9019,18 @@
   <p:clrMapOvr>
     <a:masterClrMapping/>
   </p:clrMapOvr>
+  <mc:AlternateContent xmlns:mc="http://schemas.openxmlformats.org/markup-compatibility/2006" xmlns:p14="http://schemas.microsoft.com/office/powerpoint/2010/main">
+    <mc:Choice Requires="p14">
+      <p:transition spd="med" p14:dur="700">
+        <p:fade/>
+      </p:transition>
+    </mc:Choice>
+    <mc:Fallback xmlns="">
+      <p:transition spd="med">
+        <p:fade/>
+      </p:transition>
+    </mc:Fallback>
+  </mc:AlternateContent>
   <p:timing>
     <p:tnLst>
       <p:par>
@@ -9500,6 +9497,18 @@
   <p:clrMapOvr>
     <a:masterClrMapping/>
   </p:clrMapOvr>
+  <mc:AlternateContent xmlns:mc="http://schemas.openxmlformats.org/markup-compatibility/2006" xmlns:p14="http://schemas.microsoft.com/office/powerpoint/2010/main">
+    <mc:Choice Requires="p14">
+      <p:transition spd="med" p14:dur="700">
+        <p:fade/>
+      </p:transition>
+    </mc:Choice>
+    <mc:Fallback xmlns="">
+      <p:transition spd="med">
+        <p:fade/>
+      </p:transition>
+    </mc:Fallback>
+  </mc:AlternateContent>
   <p:timing>
     <p:tnLst>
       <p:par>
@@ -9948,6 +9957,18 @@
   <p:clrMapOvr>
     <a:masterClrMapping/>
   </p:clrMapOvr>
+  <mc:AlternateContent xmlns:mc="http://schemas.openxmlformats.org/markup-compatibility/2006" xmlns:p14="http://schemas.microsoft.com/office/powerpoint/2010/main">
+    <mc:Choice Requires="p14">
+      <p:transition spd="med" p14:dur="700">
+        <p:fade/>
+      </p:transition>
+    </mc:Choice>
+    <mc:Fallback xmlns="">
+      <p:transition spd="med">
+        <p:fade/>
+      </p:transition>
+    </mc:Fallback>
+  </mc:AlternateContent>
 </p:sld>
 </file>
 
@@ -10500,6 +10521,18 @@
   <p:clrMapOvr>
     <a:masterClrMapping/>
   </p:clrMapOvr>
+  <mc:AlternateContent xmlns:mc="http://schemas.openxmlformats.org/markup-compatibility/2006" xmlns:p14="http://schemas.microsoft.com/office/powerpoint/2010/main">
+    <mc:Choice Requires="p14">
+      <p:transition spd="med" p14:dur="700">
+        <p:fade/>
+      </p:transition>
+    </mc:Choice>
+    <mc:Fallback xmlns="">
+      <p:transition spd="med">
+        <p:fade/>
+      </p:transition>
+    </mc:Fallback>
+  </mc:AlternateContent>
   <p:timing>
     <p:tnLst>
       <p:par>
@@ -11295,6 +11328,234 @@
   <p:clrMapOvr>
     <a:masterClrMapping/>
   </p:clrMapOvr>
+  <mc:AlternateContent xmlns:mc="http://schemas.openxmlformats.org/markup-compatibility/2006" xmlns:p14="http://schemas.microsoft.com/office/powerpoint/2010/main">
+    <mc:Choice Requires="p14">
+      <p:transition spd="med" p14:dur="700">
+        <p:fade/>
+      </p:transition>
+    </mc:Choice>
+    <mc:Fallback xmlns="">
+      <p:transition spd="med">
+        <p:fade/>
+      </p:transition>
+    </mc:Fallback>
+  </mc:AlternateContent>
+  <p:timing>
+    <p:tnLst>
+      <p:par>
+        <p:cTn id="1" dur="indefinite" restart="never" nodeType="tmRoot">
+          <p:childTnLst>
+            <p:seq concurrent="1" nextAc="seek">
+              <p:cTn id="2" dur="indefinite" nodeType="mainSeq">
+                <p:childTnLst>
+                  <p:par>
+                    <p:cTn id="3" fill="hold">
+                      <p:stCondLst>
+                        <p:cond delay="indefinite"/>
+                      </p:stCondLst>
+                      <p:childTnLst>
+                        <p:par>
+                          <p:cTn id="4" fill="hold">
+                            <p:stCondLst>
+                              <p:cond delay="0"/>
+                            </p:stCondLst>
+                            <p:childTnLst>
+                              <p:par>
+                                <p:cTn id="5" presetID="10" presetClass="entr" presetSubtype="0" fill="hold" grpId="0" nodeType="clickEffect">
+                                  <p:stCondLst>
+                                    <p:cond delay="0"/>
+                                  </p:stCondLst>
+                                  <p:childTnLst>
+                                    <p:set>
+                                      <p:cBhvr>
+                                        <p:cTn id="6" dur="1" fill="hold">
+                                          <p:stCondLst>
+                                            <p:cond delay="0"/>
+                                          </p:stCondLst>
+                                        </p:cTn>
+                                        <p:tgtEl>
+                                          <p:spTgt spid="3">
+                                            <p:txEl>
+                                              <p:pRg st="0" end="0"/>
+                                            </p:txEl>
+                                          </p:spTgt>
+                                        </p:tgtEl>
+                                        <p:attrNameLst>
+                                          <p:attrName>style.visibility</p:attrName>
+                                        </p:attrNameLst>
+                                      </p:cBhvr>
+                                      <p:to>
+                                        <p:strVal val="visible"/>
+                                      </p:to>
+                                    </p:set>
+                                    <p:animEffect transition="in" filter="fade">
+                                      <p:cBhvr>
+                                        <p:cTn id="7" dur="500"/>
+                                        <p:tgtEl>
+                                          <p:spTgt spid="3">
+                                            <p:txEl>
+                                              <p:pRg st="0" end="0"/>
+                                            </p:txEl>
+                                          </p:spTgt>
+                                        </p:tgtEl>
+                                      </p:cBhvr>
+                                    </p:animEffect>
+                                  </p:childTnLst>
+                                </p:cTn>
+                              </p:par>
+                            </p:childTnLst>
+                          </p:cTn>
+                        </p:par>
+                      </p:childTnLst>
+                    </p:cTn>
+                  </p:par>
+                  <p:par>
+                    <p:cTn id="8" fill="hold">
+                      <p:stCondLst>
+                        <p:cond delay="indefinite"/>
+                      </p:stCondLst>
+                      <p:childTnLst>
+                        <p:par>
+                          <p:cTn id="9" fill="hold">
+                            <p:stCondLst>
+                              <p:cond delay="0"/>
+                            </p:stCondLst>
+                            <p:childTnLst>
+                              <p:par>
+                                <p:cTn id="10" presetID="10" presetClass="entr" presetSubtype="0" fill="hold" grpId="0" nodeType="clickEffect">
+                                  <p:stCondLst>
+                                    <p:cond delay="0"/>
+                                  </p:stCondLst>
+                                  <p:childTnLst>
+                                    <p:set>
+                                      <p:cBhvr>
+                                        <p:cTn id="11" dur="1" fill="hold">
+                                          <p:stCondLst>
+                                            <p:cond delay="0"/>
+                                          </p:stCondLst>
+                                        </p:cTn>
+                                        <p:tgtEl>
+                                          <p:spTgt spid="3">
+                                            <p:txEl>
+                                              <p:pRg st="1" end="1"/>
+                                            </p:txEl>
+                                          </p:spTgt>
+                                        </p:tgtEl>
+                                        <p:attrNameLst>
+                                          <p:attrName>style.visibility</p:attrName>
+                                        </p:attrNameLst>
+                                      </p:cBhvr>
+                                      <p:to>
+                                        <p:strVal val="visible"/>
+                                      </p:to>
+                                    </p:set>
+                                    <p:animEffect transition="in" filter="fade">
+                                      <p:cBhvr>
+                                        <p:cTn id="12" dur="500"/>
+                                        <p:tgtEl>
+                                          <p:spTgt spid="3">
+                                            <p:txEl>
+                                              <p:pRg st="1" end="1"/>
+                                            </p:txEl>
+                                          </p:spTgt>
+                                        </p:tgtEl>
+                                      </p:cBhvr>
+                                    </p:animEffect>
+                                  </p:childTnLst>
+                                </p:cTn>
+                              </p:par>
+                            </p:childTnLst>
+                          </p:cTn>
+                        </p:par>
+                      </p:childTnLst>
+                    </p:cTn>
+                  </p:par>
+                  <p:par>
+                    <p:cTn id="13" fill="hold">
+                      <p:stCondLst>
+                        <p:cond delay="indefinite"/>
+                      </p:stCondLst>
+                      <p:childTnLst>
+                        <p:par>
+                          <p:cTn id="14" fill="hold">
+                            <p:stCondLst>
+                              <p:cond delay="0"/>
+                            </p:stCondLst>
+                            <p:childTnLst>
+                              <p:par>
+                                <p:cTn id="15" presetID="10" presetClass="entr" presetSubtype="0" fill="hold" grpId="0" nodeType="clickEffect">
+                                  <p:stCondLst>
+                                    <p:cond delay="0"/>
+                                  </p:stCondLst>
+                                  <p:childTnLst>
+                                    <p:set>
+                                      <p:cBhvr>
+                                        <p:cTn id="16" dur="1" fill="hold">
+                                          <p:stCondLst>
+                                            <p:cond delay="0"/>
+                                          </p:stCondLst>
+                                        </p:cTn>
+                                        <p:tgtEl>
+                                          <p:spTgt spid="3">
+                                            <p:txEl>
+                                              <p:pRg st="2" end="2"/>
+                                            </p:txEl>
+                                          </p:spTgt>
+                                        </p:tgtEl>
+                                        <p:attrNameLst>
+                                          <p:attrName>style.visibility</p:attrName>
+                                        </p:attrNameLst>
+                                      </p:cBhvr>
+                                      <p:to>
+                                        <p:strVal val="visible"/>
+                                      </p:to>
+                                    </p:set>
+                                    <p:animEffect transition="in" filter="fade">
+                                      <p:cBhvr>
+                                        <p:cTn id="17" dur="500"/>
+                                        <p:tgtEl>
+                                          <p:spTgt spid="3">
+                                            <p:txEl>
+                                              <p:pRg st="2" end="2"/>
+                                            </p:txEl>
+                                          </p:spTgt>
+                                        </p:tgtEl>
+                                      </p:cBhvr>
+                                    </p:animEffect>
+                                  </p:childTnLst>
+                                </p:cTn>
+                              </p:par>
+                            </p:childTnLst>
+                          </p:cTn>
+                        </p:par>
+                      </p:childTnLst>
+                    </p:cTn>
+                  </p:par>
+                </p:childTnLst>
+              </p:cTn>
+              <p:prevCondLst>
+                <p:cond evt="onPrev" delay="0">
+                  <p:tgtEl>
+                    <p:sldTgt/>
+                  </p:tgtEl>
+                </p:cond>
+              </p:prevCondLst>
+              <p:nextCondLst>
+                <p:cond evt="onNext" delay="0">
+                  <p:tgtEl>
+                    <p:sldTgt/>
+                  </p:tgtEl>
+                </p:cond>
+              </p:nextCondLst>
+            </p:seq>
+          </p:childTnLst>
+        </p:cTn>
+      </p:par>
+    </p:tnLst>
+    <p:bldLst>
+      <p:bldP spid="3" grpId="0" build="p"/>
+    </p:bldLst>
+  </p:timing>
 </p:sld>
 </file>
 
@@ -11357,6 +11618,18 @@
   <p:clrMapOvr>
     <a:masterClrMapping/>
   </p:clrMapOvr>
+  <mc:AlternateContent xmlns:mc="http://schemas.openxmlformats.org/markup-compatibility/2006" xmlns:p14="http://schemas.microsoft.com/office/powerpoint/2010/main">
+    <mc:Choice Requires="p14">
+      <p:transition spd="med" p14:dur="700">
+        <p:fade/>
+      </p:transition>
+    </mc:Choice>
+    <mc:Fallback xmlns="">
+      <p:transition spd="med">
+        <p:fade/>
+      </p:transition>
+    </mc:Fallback>
+  </mc:AlternateContent>
 </p:sld>
 </file>
 
@@ -11514,6 +11787,18 @@
   <p:clrMapOvr>
     <a:masterClrMapping/>
   </p:clrMapOvr>
+  <mc:AlternateContent xmlns:mc="http://schemas.openxmlformats.org/markup-compatibility/2006" xmlns:p14="http://schemas.microsoft.com/office/powerpoint/2010/main">
+    <mc:Choice Requires="p14">
+      <p:transition spd="med" p14:dur="700">
+        <p:fade/>
+      </p:transition>
+    </mc:Choice>
+    <mc:Fallback xmlns="">
+      <p:transition spd="med">
+        <p:fade/>
+      </p:transition>
+    </mc:Fallback>
+  </mc:AlternateContent>
   <p:timing>
     <p:tnLst>
       <p:par>
@@ -11967,6 +12252,18 @@
   <p:clrMapOvr>
     <a:masterClrMapping/>
   </p:clrMapOvr>
+  <mc:AlternateContent xmlns:mc="http://schemas.openxmlformats.org/markup-compatibility/2006" xmlns:p14="http://schemas.microsoft.com/office/powerpoint/2010/main">
+    <mc:Choice Requires="p14">
+      <p:transition spd="med" p14:dur="700">
+        <p:fade/>
+      </p:transition>
+    </mc:Choice>
+    <mc:Fallback xmlns="">
+      <p:transition spd="med">
+        <p:fade/>
+      </p:transition>
+    </mc:Fallback>
+  </mc:AlternateContent>
   <p:timing>
     <p:tnLst>
       <p:par>
@@ -12222,8 +12519,8 @@
           </a:p>
         </p:txBody>
       </p:sp>
-      <mc:AlternateContent xmlns:mc="http://schemas.openxmlformats.org/markup-compatibility/2006">
-        <mc:Choice xmlns:a14="http://schemas.microsoft.com/office/drawing/2010/main" Requires="a14">
+      <mc:AlternateContent xmlns:mc="http://schemas.openxmlformats.org/markup-compatibility/2006" xmlns:a14="http://schemas.microsoft.com/office/drawing/2010/main">
+        <mc:Choice Requires="a14">
           <p:sp>
             <p:nvSpPr>
               <p:cNvPr id="3" name="Content Placeholder 2">
@@ -12424,7 +12721,7 @@
             </p:txBody>
           </p:sp>
         </mc:Choice>
-        <mc:Fallback>
+        <mc:Fallback xmlns="">
           <p:sp>
             <p:nvSpPr>
               <p:cNvPr id="3" name="Content Placeholder 2">
@@ -12878,6 +13175,18 @@
   <p:clrMapOvr>
     <a:masterClrMapping/>
   </p:clrMapOvr>
+  <mc:AlternateContent xmlns:mc="http://schemas.openxmlformats.org/markup-compatibility/2006" xmlns:p14="http://schemas.microsoft.com/office/powerpoint/2010/main">
+    <mc:Choice Requires="p14">
+      <p:transition spd="med" p14:dur="700">
+        <p:fade/>
+      </p:transition>
+    </mc:Choice>
+    <mc:Fallback xmlns="">
+      <p:transition spd="med">
+        <p:fade/>
+      </p:transition>
+    </mc:Fallback>
+  </mc:AlternateContent>
   <p:timing>
     <p:tnLst>
       <p:par>
@@ -13490,8 +13799,8 @@
           </p:sp>
         </mc:Fallback>
       </mc:AlternateContent>
-      <mc:AlternateContent xmlns:mc="http://schemas.openxmlformats.org/markup-compatibility/2006">
-        <mc:Choice xmlns:a14="http://schemas.microsoft.com/office/drawing/2010/main" Requires="a14">
+      <mc:AlternateContent xmlns:mc="http://schemas.openxmlformats.org/markup-compatibility/2006" xmlns:a14="http://schemas.microsoft.com/office/drawing/2010/main">
+        <mc:Choice Requires="a14">
           <p:sp>
             <p:nvSpPr>
               <p:cNvPr id="3" name="Content Placeholder 2">
@@ -13781,7 +14090,7 @@
             </p:txBody>
           </p:sp>
         </mc:Choice>
-        <mc:Fallback>
+        <mc:Fallback xmlns="">
           <p:sp>
             <p:nvSpPr>
               <p:cNvPr id="3" name="Content Placeholder 2">
@@ -13862,6 +14171,18 @@
   <p:clrMapOvr>
     <a:masterClrMapping/>
   </p:clrMapOvr>
+  <mc:AlternateContent xmlns:mc="http://schemas.openxmlformats.org/markup-compatibility/2006" xmlns:p14="http://schemas.microsoft.com/office/powerpoint/2010/main">
+    <mc:Choice Requires="p14">
+      <p:transition spd="med" p14:dur="700">
+        <p:fade/>
+      </p:transition>
+    </mc:Choice>
+    <mc:Fallback xmlns="">
+      <p:transition spd="med">
+        <p:fade/>
+      </p:transition>
+    </mc:Fallback>
+  </mc:AlternateContent>
   <p:timing>
     <p:tnLst>
       <p:par>
@@ -14998,6 +15319,18 @@
   <p:clrMapOvr>
     <a:masterClrMapping/>
   </p:clrMapOvr>
+  <mc:AlternateContent xmlns:mc="http://schemas.openxmlformats.org/markup-compatibility/2006" xmlns:p14="http://schemas.microsoft.com/office/powerpoint/2010/main">
+    <mc:Choice Requires="p14">
+      <p:transition spd="med" p14:dur="700">
+        <p:fade/>
+      </p:transition>
+    </mc:Choice>
+    <mc:Fallback xmlns="">
+      <p:transition spd="med">
+        <p:fade/>
+      </p:transition>
+    </mc:Fallback>
+  </mc:AlternateContent>
   <p:timing>
     <p:tnLst>
       <p:par>
@@ -15769,6 +16102,18 @@
   <p:clrMapOvr>
     <a:masterClrMapping/>
   </p:clrMapOvr>
+  <mc:AlternateContent xmlns:mc="http://schemas.openxmlformats.org/markup-compatibility/2006" xmlns:p14="http://schemas.microsoft.com/office/powerpoint/2010/main">
+    <mc:Choice Requires="p14">
+      <p:transition spd="med" p14:dur="700">
+        <p:fade/>
+      </p:transition>
+    </mc:Choice>
+    <mc:Fallback xmlns="">
+      <p:transition spd="med">
+        <p:fade/>
+      </p:transition>
+    </mc:Fallback>
+  </mc:AlternateContent>
   <p:timing>
     <p:tnLst>
       <p:par>
@@ -16387,6 +16732,18 @@
   <p:clrMapOvr>
     <a:masterClrMapping/>
   </p:clrMapOvr>
+  <mc:AlternateContent xmlns:mc="http://schemas.openxmlformats.org/markup-compatibility/2006" xmlns:p14="http://schemas.microsoft.com/office/powerpoint/2010/main">
+    <mc:Choice Requires="p14">
+      <p:transition spd="med" p14:dur="700">
+        <p:fade/>
+      </p:transition>
+    </mc:Choice>
+    <mc:Fallback xmlns="">
+      <p:transition spd="med">
+        <p:fade/>
+      </p:transition>
+    </mc:Fallback>
+  </mc:AlternateContent>
   <p:timing>
     <p:tnLst>
       <p:par>
@@ -16998,6 +17355,58 @@
           </a:p>
         </p:txBody>
       </p:sp>
+      <p:sp>
+        <p:nvSpPr>
+          <p:cNvPr id="5" name="Rectangle 4">
+            <a:extLst>
+              <a:ext uri="{FF2B5EF4-FFF2-40B4-BE49-F238E27FC236}">
+                <a16:creationId xmlns:a16="http://schemas.microsoft.com/office/drawing/2014/main" id="{B0074995-29C1-CB43-4C35-7C3DD4C8F73C}"/>
+              </a:ext>
+            </a:extLst>
+          </p:cNvPr>
+          <p:cNvSpPr/>
+          <p:nvPr/>
+        </p:nvSpPr>
+        <p:spPr>
+          <a:xfrm>
+            <a:off x="6460621" y="4127619"/>
+            <a:ext cx="5614586" cy="307648"/>
+          </a:xfrm>
+          <a:prstGeom prst="rect">
+            <a:avLst/>
+          </a:prstGeom>
+          <a:noFill/>
+          <a:ln>
+            <a:solidFill>
+              <a:srgbClr val="FFFF00"/>
+            </a:solidFill>
+          </a:ln>
+        </p:spPr>
+        <p:style>
+          <a:lnRef idx="2">
+            <a:schemeClr val="accent1">
+              <a:shade val="15000"/>
+            </a:schemeClr>
+          </a:lnRef>
+          <a:fillRef idx="1">
+            <a:schemeClr val="accent1"/>
+          </a:fillRef>
+          <a:effectRef idx="0">
+            <a:schemeClr val="accent1"/>
+          </a:effectRef>
+          <a:fontRef idx="minor">
+            <a:schemeClr val="lt1"/>
+          </a:fontRef>
+        </p:style>
+        <p:txBody>
+          <a:bodyPr rtlCol="0" anchor="ctr"/>
+          <a:lstStyle/>
+          <a:p>
+            <a:pPr algn="ctr"/>
+            <a:endParaRPr lang="en-GB"/>
+          </a:p>
+        </p:txBody>
+      </p:sp>
     </p:spTree>
     <p:extLst>
       <p:ext uri="{BB962C8B-B14F-4D97-AF65-F5344CB8AC3E}">
@@ -17008,6 +17417,331 @@
   <p:clrMapOvr>
     <a:masterClrMapping/>
   </p:clrMapOvr>
+  <mc:AlternateContent xmlns:mc="http://schemas.openxmlformats.org/markup-compatibility/2006" xmlns:p14="http://schemas.microsoft.com/office/powerpoint/2010/main">
+    <mc:Choice Requires="p14">
+      <p:transition spd="med" p14:dur="700">
+        <p:fade/>
+      </p:transition>
+    </mc:Choice>
+    <mc:Fallback xmlns="">
+      <p:transition spd="med">
+        <p:fade/>
+      </p:transition>
+    </mc:Fallback>
+  </mc:AlternateContent>
+  <p:timing>
+    <p:tnLst>
+      <p:par>
+        <p:cTn id="1" dur="indefinite" restart="never" nodeType="tmRoot">
+          <p:childTnLst>
+            <p:seq concurrent="1" nextAc="seek">
+              <p:cTn id="2" dur="indefinite" nodeType="mainSeq">
+                <p:childTnLst>
+                  <p:par>
+                    <p:cTn id="3" fill="hold">
+                      <p:stCondLst>
+                        <p:cond delay="indefinite"/>
+                      </p:stCondLst>
+                      <p:childTnLst>
+                        <p:par>
+                          <p:cTn id="4" fill="hold">
+                            <p:stCondLst>
+                              <p:cond delay="0"/>
+                            </p:stCondLst>
+                            <p:childTnLst>
+                              <p:par>
+                                <p:cTn id="5" presetID="10" presetClass="entr" presetSubtype="0" fill="hold" grpId="0" nodeType="clickEffect">
+                                  <p:stCondLst>
+                                    <p:cond delay="0"/>
+                                  </p:stCondLst>
+                                  <p:childTnLst>
+                                    <p:set>
+                                      <p:cBhvr>
+                                        <p:cTn id="6" dur="1" fill="hold">
+                                          <p:stCondLst>
+                                            <p:cond delay="0"/>
+                                          </p:stCondLst>
+                                        </p:cTn>
+                                        <p:tgtEl>
+                                          <p:spTgt spid="3">
+                                            <p:txEl>
+                                              <p:pRg st="0" end="0"/>
+                                            </p:txEl>
+                                          </p:spTgt>
+                                        </p:tgtEl>
+                                        <p:attrNameLst>
+                                          <p:attrName>style.visibility</p:attrName>
+                                        </p:attrNameLst>
+                                      </p:cBhvr>
+                                      <p:to>
+                                        <p:strVal val="visible"/>
+                                      </p:to>
+                                    </p:set>
+                                    <p:animEffect transition="in" filter="fade">
+                                      <p:cBhvr>
+                                        <p:cTn id="7" dur="500"/>
+                                        <p:tgtEl>
+                                          <p:spTgt spid="3">
+                                            <p:txEl>
+                                              <p:pRg st="0" end="0"/>
+                                            </p:txEl>
+                                          </p:spTgt>
+                                        </p:tgtEl>
+                                      </p:cBhvr>
+                                    </p:animEffect>
+                                  </p:childTnLst>
+                                </p:cTn>
+                              </p:par>
+                              <p:par>
+                                <p:cTn id="8" presetID="10" presetClass="entr" presetSubtype="0" fill="hold" grpId="0" nodeType="withEffect">
+                                  <p:stCondLst>
+                                    <p:cond delay="0"/>
+                                  </p:stCondLst>
+                                  <p:childTnLst>
+                                    <p:set>
+                                      <p:cBhvr>
+                                        <p:cTn id="9" dur="1" fill="hold">
+                                          <p:stCondLst>
+                                            <p:cond delay="0"/>
+                                          </p:stCondLst>
+                                        </p:cTn>
+                                        <p:tgtEl>
+                                          <p:spTgt spid="5"/>
+                                        </p:tgtEl>
+                                        <p:attrNameLst>
+                                          <p:attrName>style.visibility</p:attrName>
+                                        </p:attrNameLst>
+                                      </p:cBhvr>
+                                      <p:to>
+                                        <p:strVal val="visible"/>
+                                      </p:to>
+                                    </p:set>
+                                    <p:animEffect transition="in" filter="fade">
+                                      <p:cBhvr>
+                                        <p:cTn id="10" dur="500"/>
+                                        <p:tgtEl>
+                                          <p:spTgt spid="5"/>
+                                        </p:tgtEl>
+                                      </p:cBhvr>
+                                    </p:animEffect>
+                                  </p:childTnLst>
+                                </p:cTn>
+                              </p:par>
+                            </p:childTnLst>
+                          </p:cTn>
+                        </p:par>
+                      </p:childTnLst>
+                    </p:cTn>
+                  </p:par>
+                  <p:par>
+                    <p:cTn id="11" fill="hold">
+                      <p:stCondLst>
+                        <p:cond delay="indefinite"/>
+                      </p:stCondLst>
+                      <p:childTnLst>
+                        <p:par>
+                          <p:cTn id="12" fill="hold">
+                            <p:stCondLst>
+                              <p:cond delay="0"/>
+                            </p:stCondLst>
+                            <p:childTnLst>
+                              <p:par>
+                                <p:cTn id="13" presetID="10" presetClass="entr" presetSubtype="0" fill="hold" grpId="0" nodeType="clickEffect">
+                                  <p:stCondLst>
+                                    <p:cond delay="0"/>
+                                  </p:stCondLst>
+                                  <p:childTnLst>
+                                    <p:set>
+                                      <p:cBhvr>
+                                        <p:cTn id="14" dur="1" fill="hold">
+                                          <p:stCondLst>
+                                            <p:cond delay="0"/>
+                                          </p:stCondLst>
+                                        </p:cTn>
+                                        <p:tgtEl>
+                                          <p:spTgt spid="3">
+                                            <p:txEl>
+                                              <p:pRg st="1" end="1"/>
+                                            </p:txEl>
+                                          </p:spTgt>
+                                        </p:tgtEl>
+                                        <p:attrNameLst>
+                                          <p:attrName>style.visibility</p:attrName>
+                                        </p:attrNameLst>
+                                      </p:cBhvr>
+                                      <p:to>
+                                        <p:strVal val="visible"/>
+                                      </p:to>
+                                    </p:set>
+                                    <p:animEffect transition="in" filter="fade">
+                                      <p:cBhvr>
+                                        <p:cTn id="15" dur="500"/>
+                                        <p:tgtEl>
+                                          <p:spTgt spid="3">
+                                            <p:txEl>
+                                              <p:pRg st="1" end="1"/>
+                                            </p:txEl>
+                                          </p:spTgt>
+                                        </p:tgtEl>
+                                      </p:cBhvr>
+                                    </p:animEffect>
+                                  </p:childTnLst>
+                                </p:cTn>
+                              </p:par>
+                            </p:childTnLst>
+                          </p:cTn>
+                        </p:par>
+                      </p:childTnLst>
+                    </p:cTn>
+                  </p:par>
+                  <p:par>
+                    <p:cTn id="16" fill="hold">
+                      <p:stCondLst>
+                        <p:cond delay="indefinite"/>
+                      </p:stCondLst>
+                      <p:childTnLst>
+                        <p:par>
+                          <p:cTn id="17" fill="hold">
+                            <p:stCondLst>
+                              <p:cond delay="0"/>
+                            </p:stCondLst>
+                            <p:childTnLst>
+                              <p:par>
+                                <p:cTn id="18" presetID="10" presetClass="entr" presetSubtype="0" fill="hold" grpId="0" nodeType="clickEffect">
+                                  <p:stCondLst>
+                                    <p:cond delay="0"/>
+                                  </p:stCondLst>
+                                  <p:childTnLst>
+                                    <p:set>
+                                      <p:cBhvr>
+                                        <p:cTn id="19" dur="1" fill="hold">
+                                          <p:stCondLst>
+                                            <p:cond delay="0"/>
+                                          </p:stCondLst>
+                                        </p:cTn>
+                                        <p:tgtEl>
+                                          <p:spTgt spid="3">
+                                            <p:txEl>
+                                              <p:pRg st="2" end="2"/>
+                                            </p:txEl>
+                                          </p:spTgt>
+                                        </p:tgtEl>
+                                        <p:attrNameLst>
+                                          <p:attrName>style.visibility</p:attrName>
+                                        </p:attrNameLst>
+                                      </p:cBhvr>
+                                      <p:to>
+                                        <p:strVal val="visible"/>
+                                      </p:to>
+                                    </p:set>
+                                    <p:animEffect transition="in" filter="fade">
+                                      <p:cBhvr>
+                                        <p:cTn id="20" dur="500"/>
+                                        <p:tgtEl>
+                                          <p:spTgt spid="3">
+                                            <p:txEl>
+                                              <p:pRg st="2" end="2"/>
+                                            </p:txEl>
+                                          </p:spTgt>
+                                        </p:tgtEl>
+                                      </p:cBhvr>
+                                    </p:animEffect>
+                                  </p:childTnLst>
+                                </p:cTn>
+                              </p:par>
+                            </p:childTnLst>
+                          </p:cTn>
+                        </p:par>
+                      </p:childTnLst>
+                    </p:cTn>
+                  </p:par>
+                  <p:par>
+                    <p:cTn id="21" fill="hold">
+                      <p:stCondLst>
+                        <p:cond delay="indefinite"/>
+                      </p:stCondLst>
+                      <p:childTnLst>
+                        <p:par>
+                          <p:cTn id="22" fill="hold">
+                            <p:stCondLst>
+                              <p:cond delay="0"/>
+                            </p:stCondLst>
+                            <p:childTnLst>
+                              <p:par>
+                                <p:cTn id="23" presetID="10" presetClass="entr" presetSubtype="0" fill="hold" grpId="0" nodeType="clickEffect">
+                                  <p:stCondLst>
+                                    <p:cond delay="0"/>
+                                  </p:stCondLst>
+                                  <p:childTnLst>
+                                    <p:set>
+                                      <p:cBhvr>
+                                        <p:cTn id="24" dur="1" fill="hold">
+                                          <p:stCondLst>
+                                            <p:cond delay="0"/>
+                                          </p:stCondLst>
+                                        </p:cTn>
+                                        <p:tgtEl>
+                                          <p:spTgt spid="3">
+                                            <p:txEl>
+                                              <p:pRg st="3" end="3"/>
+                                            </p:txEl>
+                                          </p:spTgt>
+                                        </p:tgtEl>
+                                        <p:attrNameLst>
+                                          <p:attrName>style.visibility</p:attrName>
+                                        </p:attrNameLst>
+                                      </p:cBhvr>
+                                      <p:to>
+                                        <p:strVal val="visible"/>
+                                      </p:to>
+                                    </p:set>
+                                    <p:animEffect transition="in" filter="fade">
+                                      <p:cBhvr>
+                                        <p:cTn id="25" dur="500"/>
+                                        <p:tgtEl>
+                                          <p:spTgt spid="3">
+                                            <p:txEl>
+                                              <p:pRg st="3" end="3"/>
+                                            </p:txEl>
+                                          </p:spTgt>
+                                        </p:tgtEl>
+                                      </p:cBhvr>
+                                    </p:animEffect>
+                                  </p:childTnLst>
+                                </p:cTn>
+                              </p:par>
+                            </p:childTnLst>
+                          </p:cTn>
+                        </p:par>
+                      </p:childTnLst>
+                    </p:cTn>
+                  </p:par>
+                </p:childTnLst>
+              </p:cTn>
+              <p:prevCondLst>
+                <p:cond evt="onPrev" delay="0">
+                  <p:tgtEl>
+                    <p:sldTgt/>
+                  </p:tgtEl>
+                </p:cond>
+              </p:prevCondLst>
+              <p:nextCondLst>
+                <p:cond evt="onNext" delay="0">
+                  <p:tgtEl>
+                    <p:sldTgt/>
+                  </p:tgtEl>
+                </p:cond>
+              </p:nextCondLst>
+            </p:seq>
+          </p:childTnLst>
+        </p:cTn>
+      </p:par>
+    </p:tnLst>
+    <p:bldLst>
+      <p:bldP spid="3" grpId="0" uiExpand="1" build="p"/>
+      <p:bldP spid="5" grpId="0" animBg="1"/>
+    </p:bldLst>
+  </p:timing>
 </p:sld>
 </file>
 
@@ -17066,6 +17800,18 @@
   <p:clrMapOvr>
     <a:masterClrMapping/>
   </p:clrMapOvr>
+  <mc:AlternateContent xmlns:mc="http://schemas.openxmlformats.org/markup-compatibility/2006" xmlns:p14="http://schemas.microsoft.com/office/powerpoint/2010/main">
+    <mc:Choice Requires="p14">
+      <p:transition spd="med" p14:dur="700">
+        <p:fade/>
+      </p:transition>
+    </mc:Choice>
+    <mc:Fallback xmlns="">
+      <p:transition spd="med">
+        <p:fade/>
+      </p:transition>
+    </mc:Fallback>
+  </mc:AlternateContent>
 </p:sld>
 </file>
 
@@ -17440,6 +18186,18 @@
   <p:clrMapOvr>
     <a:masterClrMapping/>
   </p:clrMapOvr>
+  <mc:AlternateContent xmlns:mc="http://schemas.openxmlformats.org/markup-compatibility/2006" xmlns:p14="http://schemas.microsoft.com/office/powerpoint/2010/main">
+    <mc:Choice Requires="p14">
+      <p:transition spd="med" p14:dur="700">
+        <p:fade/>
+      </p:transition>
+    </mc:Choice>
+    <mc:Fallback xmlns="">
+      <p:transition spd="med">
+        <p:fade/>
+      </p:transition>
+    </mc:Fallback>
+  </mc:AlternateContent>
   <p:timing>
     <p:tnLst>
       <p:par>
@@ -17850,6 +18608,18 @@
   <p:clrMapOvr>
     <a:masterClrMapping/>
   </p:clrMapOvr>
+  <mc:AlternateContent xmlns:mc="http://schemas.openxmlformats.org/markup-compatibility/2006" xmlns:p14="http://schemas.microsoft.com/office/powerpoint/2010/main">
+    <mc:Choice Requires="p14">
+      <p:transition spd="med" p14:dur="700">
+        <p:fade/>
+      </p:transition>
+    </mc:Choice>
+    <mc:Fallback xmlns="">
+      <p:transition spd="med">
+        <p:fade/>
+      </p:transition>
+    </mc:Fallback>
+  </mc:AlternateContent>
   <p:timing>
     <p:tnLst>
       <p:par>
@@ -18424,6 +19194,18 @@
   <p:clrMapOvr>
     <a:masterClrMapping/>
   </p:clrMapOvr>
+  <mc:AlternateContent xmlns:mc="http://schemas.openxmlformats.org/markup-compatibility/2006" xmlns:p14="http://schemas.microsoft.com/office/powerpoint/2010/main">
+    <mc:Choice Requires="p14">
+      <p:transition spd="med" p14:dur="700">
+        <p:fade/>
+      </p:transition>
+    </mc:Choice>
+    <mc:Fallback xmlns="">
+      <p:transition spd="med">
+        <p:fade/>
+      </p:transition>
+    </mc:Fallback>
+  </mc:AlternateContent>
   <p:timing>
     <p:tnLst>
       <p:par>
@@ -19195,6 +19977,18 @@
   <p:clrMapOvr>
     <a:masterClrMapping/>
   </p:clrMapOvr>
+  <mc:AlternateContent xmlns:mc="http://schemas.openxmlformats.org/markup-compatibility/2006" xmlns:p14="http://schemas.microsoft.com/office/powerpoint/2010/main">
+    <mc:Choice Requires="p14">
+      <p:transition spd="med" p14:dur="700">
+        <p:fade/>
+      </p:transition>
+    </mc:Choice>
+    <mc:Fallback xmlns="">
+      <p:transition spd="med">
+        <p:fade/>
+      </p:transition>
+    </mc:Fallback>
+  </mc:AlternateContent>
   <p:timing>
     <p:tnLst>
       <p:par>
@@ -19607,6 +20401,18 @@
   <p:clrMapOvr>
     <a:masterClrMapping/>
   </p:clrMapOvr>
+  <mc:AlternateContent xmlns:mc="http://schemas.openxmlformats.org/markup-compatibility/2006" xmlns:p14="http://schemas.microsoft.com/office/powerpoint/2010/main">
+    <mc:Choice Requires="p14">
+      <p:transition spd="med" p14:dur="700">
+        <p:fade/>
+      </p:transition>
+    </mc:Choice>
+    <mc:Fallback xmlns="">
+      <p:transition spd="med">
+        <p:fade/>
+      </p:transition>
+    </mc:Fallback>
+  </mc:AlternateContent>
   <p:timing>
     <p:tnLst>
       <p:par>
@@ -20310,6 +21116,18 @@
   <p:clrMapOvr>
     <a:masterClrMapping/>
   </p:clrMapOvr>
+  <mc:AlternateContent xmlns:mc="http://schemas.openxmlformats.org/markup-compatibility/2006" xmlns:p14="http://schemas.microsoft.com/office/powerpoint/2010/main">
+    <mc:Choice Requires="p14">
+      <p:transition spd="med" p14:dur="700">
+        <p:fade/>
+      </p:transition>
+    </mc:Choice>
+    <mc:Fallback xmlns="">
+      <p:transition spd="med">
+        <p:fade/>
+      </p:transition>
+    </mc:Fallback>
+  </mc:AlternateContent>
   <p:timing>
     <p:tnLst>
       <p:par>
@@ -20828,6 +21646,18 @@
   <p:clrMapOvr>
     <a:masterClrMapping/>
   </p:clrMapOvr>
+  <mc:AlternateContent xmlns:mc="http://schemas.openxmlformats.org/markup-compatibility/2006" xmlns:p14="http://schemas.microsoft.com/office/powerpoint/2010/main">
+    <mc:Choice Requires="p14">
+      <p:transition spd="med" p14:dur="700">
+        <p:fade/>
+      </p:transition>
+    </mc:Choice>
+    <mc:Fallback xmlns="">
+      <p:transition spd="med">
+        <p:fade/>
+      </p:transition>
+    </mc:Fallback>
+  </mc:AlternateContent>
 </p:sld>
 </file>
 
@@ -20971,6 +21801,18 @@
   <p:clrMapOvr>
     <a:masterClrMapping/>
   </p:clrMapOvr>
+  <mc:AlternateContent xmlns:mc="http://schemas.openxmlformats.org/markup-compatibility/2006" xmlns:p14="http://schemas.microsoft.com/office/powerpoint/2010/main">
+    <mc:Choice Requires="p14">
+      <p:transition spd="med" p14:dur="700">
+        <p:fade/>
+      </p:transition>
+    </mc:Choice>
+    <mc:Fallback xmlns="">
+      <p:transition spd="med">
+        <p:fade/>
+      </p:transition>
+    </mc:Fallback>
+  </mc:AlternateContent>
   <p:timing>
     <p:tnLst>
       <p:par>
@@ -21458,6 +22300,18 @@
   <p:clrMapOvr>
     <a:masterClrMapping/>
   </p:clrMapOvr>
+  <mc:AlternateContent xmlns:mc="http://schemas.openxmlformats.org/markup-compatibility/2006" xmlns:p14="http://schemas.microsoft.com/office/powerpoint/2010/main">
+    <mc:Choice Requires="p14">
+      <p:transition spd="med" p14:dur="700">
+        <p:fade/>
+      </p:transition>
+    </mc:Choice>
+    <mc:Fallback xmlns="">
+      <p:transition spd="med">
+        <p:fade/>
+      </p:transition>
+    </mc:Fallback>
+  </mc:AlternateContent>
   <p:timing>
     <p:tnLst>
       <p:par>
@@ -21783,8 +22637,8 @@
           </a:p>
         </p:txBody>
       </p:sp>
-      <mc:AlternateContent xmlns:mc="http://schemas.openxmlformats.org/markup-compatibility/2006">
-        <mc:Choice xmlns:a14="http://schemas.microsoft.com/office/drawing/2010/main" Requires="a14">
+      <mc:AlternateContent xmlns:mc="http://schemas.openxmlformats.org/markup-compatibility/2006" xmlns:a14="http://schemas.microsoft.com/office/drawing/2010/main">
+        <mc:Choice Requires="a14">
           <p:sp>
             <p:nvSpPr>
               <p:cNvPr id="3" name="Content Placeholder 2">
@@ -21946,7 +22800,7 @@
             </p:txBody>
           </p:sp>
         </mc:Choice>
-        <mc:Fallback>
+        <mc:Fallback xmlns="">
           <p:sp>
             <p:nvSpPr>
               <p:cNvPr id="3" name="Content Placeholder 2">
@@ -22032,6 +22886,18 @@
   <p:clrMapOvr>
     <a:masterClrMapping/>
   </p:clrMapOvr>
+  <mc:AlternateContent xmlns:mc="http://schemas.openxmlformats.org/markup-compatibility/2006" xmlns:p14="http://schemas.microsoft.com/office/powerpoint/2010/main">
+    <mc:Choice Requires="p14">
+      <p:transition spd="med" p14:dur="700">
+        <p:fade/>
+      </p:transition>
+    </mc:Choice>
+    <mc:Fallback xmlns="">
+      <p:transition spd="med">
+        <p:fade/>
+      </p:transition>
+    </mc:Fallback>
+  </mc:AlternateContent>
   <p:timing>
     <p:tnLst>
       <p:par>
@@ -22453,6 +23319,18 @@
   <p:clrMapOvr>
     <a:masterClrMapping/>
   </p:clrMapOvr>
+  <mc:AlternateContent xmlns:mc="http://schemas.openxmlformats.org/markup-compatibility/2006" xmlns:p14="http://schemas.microsoft.com/office/powerpoint/2010/main">
+    <mc:Choice Requires="p14">
+      <p:transition spd="med" p14:dur="700">
+        <p:fade/>
+      </p:transition>
+    </mc:Choice>
+    <mc:Fallback xmlns="">
+      <p:transition spd="med">
+        <p:fade/>
+      </p:transition>
+    </mc:Fallback>
+  </mc:AlternateContent>
 </p:sld>
 </file>
 
@@ -22544,7 +23422,7 @@
           <a:p>
             <a:r>
               <a:rPr lang="en-GB" dirty="0"/>
-              <a:t>E.g. how likely is it to see a 1.7 m tall Emperor penguin, given the average is 1.1 m?</a:t>
+              <a:t>E.g. how likely is it to see a 1.56 m tall Emperor penguin, given the average is 1.1 m?</a:t>
             </a:r>
           </a:p>
         </p:txBody>
@@ -22590,6 +23468,18 @@
   <p:clrMapOvr>
     <a:masterClrMapping/>
   </p:clrMapOvr>
+  <mc:AlternateContent xmlns:mc="http://schemas.openxmlformats.org/markup-compatibility/2006" xmlns:p14="http://schemas.microsoft.com/office/powerpoint/2010/main">
+    <mc:Choice Requires="p14">
+      <p:transition spd="med" p14:dur="700">
+        <p:fade/>
+      </p:transition>
+    </mc:Choice>
+    <mc:Fallback xmlns="">
+      <p:transition spd="med">
+        <p:fade/>
+      </p:transition>
+    </mc:Fallback>
+  </mc:AlternateContent>
   <p:timing>
     <p:tnLst>
       <p:par>

</xml_diff>